<commit_message>
Conectividad RM: pase de editor comercial al deck
- Corrige error factual (Batuco 'rápido' siendo 11º de 14 en la lámina de posicionamiento)
- Elimina registro deportivo ('corre') y ambigüedad en la cifra de tesis
- Poda ecos ('el argumento es el tren' quedaba en 4 insights; ahora 2)
- Reordena el arco: diagnóstico completo antes del salto; proyectos antes de debilidades
- Tijera en kickers e insights

Co-Authored-By: Claude Opus 4.8 <noreply@anthropic.com>
</commit_message>
<xml_diff>
--- a/public/conectividad/Conectividad-Modela-Directorio.pptx
+++ b/public/conectividad/Conectividad-Modela-Directorio.pptx
@@ -3661,7 +3661,7 @@
                 </a:solidFill>
                 <a:latin typeface="Helvetica Neue"/>
               </a:rPr>
-              <a:t>Menos tiempo y menos costo de traslado se capitalizan en cuánto puede pagar una familia por su vivienda. Medimos esa conexión, zona por zona, y el veredicto para nuestros proyectos es claro.</a:t>
+              <a:t>Menos tiempo y menos costo de traslado se capitalizan en cuánto puede pagar una familia por su vivienda. Medimos ese efecto, zona por zona.</a:t>
             </a:r>
           </a:p>
         </p:txBody>
@@ -4156,7 +4156,7 @@
                 </a:solidFill>
                 <a:latin typeface="Helvetica Neue"/>
               </a:rPr>
-              <a:t>UF sobre la zona peor conectada, Estación Colina</a:t>
+              <a:t>UF de Estación Colina sobre la zona peor conectada</a:t>
             </a:r>
           </a:p>
         </p:txBody>
@@ -39121,7 +39121,7 @@
                 </a:solidFill>
                 <a:latin typeface="Helvetica Neue"/>
               </a:rPr>
-              <a:t>La lectura honesta: manejar desde Batuco es caro y su sobreprecio por auto es acotado; no puede pedir más UF que Valle Grande ni Chicauma. Su diferencial de precio está en el tren.</a:t>
+              <a:t>La lectura honesta: manejar desde Batuco es caro y su sobreprecio por auto es acotado; no puede pedir más UF que Valle Grande ni Chicauma. La lámina siguiente muestra dónde recupera esa diferencia.</a:t>
             </a:r>
           </a:p>
         </p:txBody>
@@ -40085,7 +40085,7 @@
                 </a:solidFill>
                 <a:latin typeface="Helvetica Neue"/>
               </a:rPr>
-              <a:t>Es la recomendación central: gestionar la integración a RED. Baja el costo, sube el atractivo y está bajo nuestra influencia, no la de una autopista por construir.</a:t>
+              <a:t>La recomendación central: gestionar la integración a RED. Baja el costo, sube el atractivo y depende de nosotros, no de una obra por construir.</a:t>
             </a:r>
           </a:p>
         </p:txBody>

</xml_diff>